<commit_message>
feat(release): add cross-machine acceptance evidence
</commit_message>
<xml_diff>
--- a/docs/deliverables/gfm-stability-defense-deck.pptx
+++ b/docs/deliverables/gfm-stability-defense-deck.pptx
@@ -2,22 +2,22 @@
 <file path=ppt/presentation.xml><?xml version="1.0" encoding="utf-8"?>
 <p:presentation xmlns:p="http://schemas.openxmlformats.org/presentationml/2006/main">
   <p:sldMasterIdLst>
-    <p:sldMasterId xmlns:r="http://schemas.openxmlformats.org/officeDocument/2006/relationships" id="2147483648" r:id="Rfa34163657284d19"/>
+    <p:sldMasterId xmlns:r="http://schemas.openxmlformats.org/officeDocument/2006/relationships" id="2147483648" r:id="Rd7ffa8eb565e45ac"/>
   </p:sldMasterIdLst>
   <p:notesMasterIdLst>
-    <p:notesMasterId xmlns:r="http://schemas.openxmlformats.org/officeDocument/2006/relationships" r:id="R2a3f1b816d0d4ccb"/>
+    <p:notesMasterId xmlns:r="http://schemas.openxmlformats.org/officeDocument/2006/relationships" r:id="Rbdaf56c9802a4821"/>
   </p:notesMasterIdLst>
   <p:sldIdLst>
-    <p:sldId xmlns:r="http://schemas.openxmlformats.org/officeDocument/2006/relationships" id="256" r:id="R614519eca2fb40cb"/>
-    <p:sldId xmlns:r="http://schemas.openxmlformats.org/officeDocument/2006/relationships" id="257" r:id="R4016d67cb2b54321"/>
-    <p:sldId xmlns:r="http://schemas.openxmlformats.org/officeDocument/2006/relationships" id="258" r:id="Rd1722574f1ac4ba4"/>
-    <p:sldId xmlns:r="http://schemas.openxmlformats.org/officeDocument/2006/relationships" id="259" r:id="Raf350ccc20494d29"/>
-    <p:sldId xmlns:r="http://schemas.openxmlformats.org/officeDocument/2006/relationships" id="260" r:id="R64f8173336744514"/>
-    <p:sldId xmlns:r="http://schemas.openxmlformats.org/officeDocument/2006/relationships" id="261" r:id="Rab7492c0884f42b5"/>
-    <p:sldId xmlns:r="http://schemas.openxmlformats.org/officeDocument/2006/relationships" id="262" r:id="R71d8d11aa9484def"/>
-    <p:sldId xmlns:r="http://schemas.openxmlformats.org/officeDocument/2006/relationships" id="263" r:id="R97f4fc0981484e3d"/>
-    <p:sldId xmlns:r="http://schemas.openxmlformats.org/officeDocument/2006/relationships" id="264" r:id="R8b58110d9fa044f3"/>
-    <p:sldId xmlns:r="http://schemas.openxmlformats.org/officeDocument/2006/relationships" id="265" r:id="R1b0e75d7dd744b37"/>
+    <p:sldId xmlns:r="http://schemas.openxmlformats.org/officeDocument/2006/relationships" id="256" r:id="R91b4de300d6f44b4"/>
+    <p:sldId xmlns:r="http://schemas.openxmlformats.org/officeDocument/2006/relationships" id="257" r:id="R2adac11b6c6b4186"/>
+    <p:sldId xmlns:r="http://schemas.openxmlformats.org/officeDocument/2006/relationships" id="258" r:id="R5462799807b14871"/>
+    <p:sldId xmlns:r="http://schemas.openxmlformats.org/officeDocument/2006/relationships" id="259" r:id="Rc19bafea712e4f0e"/>
+    <p:sldId xmlns:r="http://schemas.openxmlformats.org/officeDocument/2006/relationships" id="260" r:id="R558b47bf5db54c6b"/>
+    <p:sldId xmlns:r="http://schemas.openxmlformats.org/officeDocument/2006/relationships" id="261" r:id="R8d9a6ee03b9d4e64"/>
+    <p:sldId xmlns:r="http://schemas.openxmlformats.org/officeDocument/2006/relationships" id="262" r:id="Rca5635c012a54492"/>
+    <p:sldId xmlns:r="http://schemas.openxmlformats.org/officeDocument/2006/relationships" id="263" r:id="Ra0af7809b5bf4fc3"/>
+    <p:sldId xmlns:r="http://schemas.openxmlformats.org/officeDocument/2006/relationships" id="264" r:id="R52fc50450e9d4670"/>
+    <p:sldId xmlns:r="http://schemas.openxmlformats.org/officeDocument/2006/relationships" id="265" r:id="Rf0426b011bff4300"/>
   </p:sldIdLst>
   <p:sldSz cx="12192000" cy="6858000"/>
   <p:notesSz cx="6858000" cy="9144000"/>
@@ -1409,7 +1409,7 @@
   </p:cSld>
   <p:clrMap bg1="lt1" tx1="dk1" bg2="lt2" tx2="dk2" accent1="accent1" accent2="accent2" accent3="accent3" accent4="accent4" accent5="accent5" accent6="accent6" hlink="hlink" folHlink="folHlink"/>
   <p:sldLayoutIdLst>
-    <p:sldLayoutId xmlns:r="http://schemas.openxmlformats.org/officeDocument/2006/relationships" id="2147483649" r:id="Re6ccdc0dc0514a97"/>
+    <p:sldLayoutId xmlns:r="http://schemas.openxmlformats.org/officeDocument/2006/relationships" id="2147483649" r:id="R4defa0f2004c414e"/>
   </p:sldLayoutIdLst>
   <p:txStyles>
     <p:titleStyle>
@@ -1953,7 +1953,7 @@
           <p:cNvPr id="4" name="Title-3-1">
             <a:extLst xmlns:a="http://schemas.openxmlformats.org/drawingml/2006/main">
               <a:ext uri="{FF2B5EF4-FFF2-40B4-BE49-F238E27FC236}">
-                <a16:creationId xmlns:a16="http://schemas.microsoft.com/office/drawing/2014/main" id="{0347BACE-B4BC-4EB9-AD31-B1983625370E}"/>
+                <a16:creationId xmlns:a16="http://schemas.microsoft.com/office/drawing/2014/main" id="{EE80A4D7-D89C-4C84-8737-37C2D12600B8}"/>
               </a:ext>
             </a:extLst>
           </p:cNvPr>
@@ -2011,7 +2011,7 @@
           <p:cNvPr id="2" name="Subtitle-4-2">
             <a:extLst xmlns:a="http://schemas.openxmlformats.org/drawingml/2006/main">
               <a:ext uri="{FF2B5EF4-FFF2-40B4-BE49-F238E27FC236}">
-                <a16:creationId xmlns:a16="http://schemas.microsoft.com/office/drawing/2014/main" id="{D2EF71E4-4DC6-40F7-ACA1-C1826E1AAF4E}"/>
+                <a16:creationId xmlns:a16="http://schemas.microsoft.com/office/drawing/2014/main" id="{9FEBD47F-3F42-471E-B071-57DD5823DE56}"/>
               </a:ext>
             </a:extLst>
           </p:cNvPr>
@@ -2068,7 +2068,7 @@
           <p:cNvPr id="3" name="Subtitle-4-3">
             <a:extLst xmlns:a="http://schemas.openxmlformats.org/drawingml/2006/main">
               <a:ext uri="{FF2B5EF4-FFF2-40B4-BE49-F238E27FC236}">
-                <a16:creationId xmlns:a16="http://schemas.microsoft.com/office/drawing/2014/main" id="{EB92703F-0E14-4B30-B34A-25453E9DC59B}"/>
+                <a16:creationId xmlns:a16="http://schemas.microsoft.com/office/drawing/2014/main" id="{621F2B06-94E9-47C7-AEDC-9A139D961D1A}"/>
               </a:ext>
             </a:extLst>
           </p:cNvPr>
@@ -2123,7 +2123,7 @@
     </p:spTree>
     <p:extLst>
       <p:ext uri="{BB962C8B-B14F-4D97-AF65-F5344CB8AC3E}">
-        <p14:creationId xmlns:p14="http://schemas.microsoft.com/office/powerpoint/2010/main" val="873139086"/>
+        <p14:creationId xmlns:p14="http://schemas.microsoft.com/office/powerpoint/2010/main" val="703291318"/>
       </p:ext>
     </p:extLst>
   </p:cSld>
@@ -2147,7 +2147,7 @@
           <p:cNvPr id="4" name="Title-3-1">
             <a:extLst xmlns:a="http://schemas.openxmlformats.org/drawingml/2006/main">
               <a:ext uri="{FF2B5EF4-FFF2-40B4-BE49-F238E27FC236}">
-                <a16:creationId xmlns:a16="http://schemas.microsoft.com/office/drawing/2014/main" id="{BF8F409F-4A12-46B7-8C22-D500A29F8FCA}"/>
+                <a16:creationId xmlns:a16="http://schemas.microsoft.com/office/drawing/2014/main" id="{7A83FE2E-C062-4680-AC75-F3FBBE9DBB09}"/>
               </a:ext>
             </a:extLst>
           </p:cNvPr>
@@ -2205,7 +2205,7 @@
           <p:cNvPr id="2" name="Subtitle-4-2">
             <a:extLst xmlns:a="http://schemas.openxmlformats.org/drawingml/2006/main">
               <a:ext uri="{FF2B5EF4-FFF2-40B4-BE49-F238E27FC236}">
-                <a16:creationId xmlns:a16="http://schemas.microsoft.com/office/drawing/2014/main" id="{D35F45D6-06AC-4FB1-9F7C-EAD172C004BA}"/>
+                <a16:creationId xmlns:a16="http://schemas.microsoft.com/office/drawing/2014/main" id="{DF91A980-CDE4-4DFA-A8E8-A497634EC5BA}"/>
               </a:ext>
             </a:extLst>
           </p:cNvPr>
@@ -2316,7 +2316,7 @@
           <p:cNvPr id="3" name="Subtitle-4-3">
             <a:extLst xmlns:a="http://schemas.openxmlformats.org/drawingml/2006/main">
               <a:ext uri="{FF2B5EF4-FFF2-40B4-BE49-F238E27FC236}">
-                <a16:creationId xmlns:a16="http://schemas.microsoft.com/office/drawing/2014/main" id="{1C79C084-5615-41BA-BBC5-D2741D3FEA6F}"/>
+                <a16:creationId xmlns:a16="http://schemas.microsoft.com/office/drawing/2014/main" id="{D936E609-5D6E-49D9-AE4C-7A9B19B2A389}"/>
               </a:ext>
             </a:extLst>
           </p:cNvPr>
@@ -2371,7 +2371,7 @@
     </p:spTree>
     <p:extLst>
       <p:ext uri="{BB962C8B-B14F-4D97-AF65-F5344CB8AC3E}">
-        <p14:creationId xmlns:p14="http://schemas.microsoft.com/office/powerpoint/2010/main" val="606972853"/>
+        <p14:creationId xmlns:p14="http://schemas.microsoft.com/office/powerpoint/2010/main" val="1399236552"/>
       </p:ext>
     </p:extLst>
   </p:cSld>
@@ -2395,7 +2395,7 @@
           <p:cNvPr id="6" name="Google-Shape-532-p58-2">
             <a:extLst xmlns:a="http://schemas.openxmlformats.org/drawingml/2006/main">
               <a:ext uri="{FF2B5EF4-FFF2-40B4-BE49-F238E27FC236}">
-                <a16:creationId xmlns:a16="http://schemas.microsoft.com/office/drawing/2014/main" id="{E851034D-021F-41D1-9B02-7BDE465A719F}"/>
+                <a16:creationId xmlns:a16="http://schemas.microsoft.com/office/drawing/2014/main" id="{54D102AA-B6BF-4C6C-8621-C024EFA0827E}"/>
               </a:ext>
             </a:extLst>
           </p:cNvPr>
@@ -2452,7 +2452,7 @@
           <p:cNvPr id="2" name="Google-Shape-533-p58-3">
             <a:extLst xmlns:a="http://schemas.openxmlformats.org/drawingml/2006/main">
               <a:ext uri="{FF2B5EF4-FFF2-40B4-BE49-F238E27FC236}">
-                <a16:creationId xmlns:a16="http://schemas.microsoft.com/office/drawing/2014/main" id="{D8371818-70AD-457D-BE35-FAE17082EA47}"/>
+                <a16:creationId xmlns:a16="http://schemas.microsoft.com/office/drawing/2014/main" id="{1EAD8522-2F1B-4C14-8765-95FFA39C5848}"/>
               </a:ext>
             </a:extLst>
           </p:cNvPr>
@@ -2509,7 +2509,7 @@
           <p:cNvPr id="3" name="Google-Shape-534-p58-4">
             <a:extLst xmlns:a="http://schemas.openxmlformats.org/drawingml/2006/main">
               <a:ext uri="{FF2B5EF4-FFF2-40B4-BE49-F238E27FC236}">
-                <a16:creationId xmlns:a16="http://schemas.microsoft.com/office/drawing/2014/main" id="{5FEE85F3-4056-4EC4-855A-03DBC969E5EF}"/>
+                <a16:creationId xmlns:a16="http://schemas.microsoft.com/office/drawing/2014/main" id="{E9111173-3E40-4931-A499-DE7208A7DB7C}"/>
               </a:ext>
             </a:extLst>
           </p:cNvPr>
@@ -2594,7 +2594,7 @@
           <p:cNvPr id="4" name="Content-Placeholder-1-5">
             <a:extLst xmlns:a="http://schemas.openxmlformats.org/drawingml/2006/main">
               <a:ext uri="{FF2B5EF4-FFF2-40B4-BE49-F238E27FC236}">
-                <a16:creationId xmlns:a16="http://schemas.microsoft.com/office/drawing/2014/main" id="{4A1A9440-287E-4308-B74C-BFFB5C114B56}"/>
+                <a16:creationId xmlns:a16="http://schemas.microsoft.com/office/drawing/2014/main" id="{C0BC69FF-4B9D-4668-8688-0524DCE3CA44}"/>
               </a:ext>
             </a:extLst>
           </p:cNvPr>
@@ -2679,7 +2679,7 @@
           <p:cNvPr id="5" name="Content-Placeholder-2-6">
             <a:extLst xmlns:a="http://schemas.openxmlformats.org/drawingml/2006/main">
               <a:ext uri="{FF2B5EF4-FFF2-40B4-BE49-F238E27FC236}">
-                <a16:creationId xmlns:a16="http://schemas.microsoft.com/office/drawing/2014/main" id="{FED683C2-C4CE-48F2-9212-B737A8D7187F}"/>
+                <a16:creationId xmlns:a16="http://schemas.microsoft.com/office/drawing/2014/main" id="{D1D77CA8-B4B0-4D83-B711-17D07B70FEBF}"/>
               </a:ext>
             </a:extLst>
           </p:cNvPr>
@@ -2762,7 +2762,7 @@
     </p:spTree>
     <p:extLst>
       <p:ext uri="{BB962C8B-B14F-4D97-AF65-F5344CB8AC3E}">
-        <p14:creationId xmlns:p14="http://schemas.microsoft.com/office/powerpoint/2010/main" val="1481817240"/>
+        <p14:creationId xmlns:p14="http://schemas.microsoft.com/office/powerpoint/2010/main" val="304371817"/>
       </p:ext>
     </p:extLst>
   </p:cSld>
@@ -2786,7 +2786,7 @@
           <p:cNvPr id="13" name="Slide-Number-Placeholder-3-2">
             <a:extLst xmlns:a="http://schemas.openxmlformats.org/drawingml/2006/main">
               <a:ext uri="{FF2B5EF4-FFF2-40B4-BE49-F238E27FC236}">
-                <a16:creationId xmlns:a16="http://schemas.microsoft.com/office/drawing/2014/main" id="{4941FCED-4B7F-4A51-9C88-69EA3CD533DC}"/>
+                <a16:creationId xmlns:a16="http://schemas.microsoft.com/office/drawing/2014/main" id="{8E6413C2-C944-4E5F-89E7-2C4179C3459F}"/>
               </a:ext>
             </a:extLst>
           </p:cNvPr>
@@ -2841,7 +2841,7 @@
           <p:cNvPr id="2" name="Title-10-3">
             <a:extLst xmlns:a="http://schemas.openxmlformats.org/drawingml/2006/main">
               <a:ext uri="{FF2B5EF4-FFF2-40B4-BE49-F238E27FC236}">
-                <a16:creationId xmlns:a16="http://schemas.microsoft.com/office/drawing/2014/main" id="{44E98798-3DAA-446D-AE1D-7A8783445157}"/>
+                <a16:creationId xmlns:a16="http://schemas.microsoft.com/office/drawing/2014/main" id="{D5EFFF4E-6530-42AE-B150-09DD839D958F}"/>
               </a:ext>
             </a:extLst>
           </p:cNvPr>
@@ -2920,7 +2920,7 @@
           <p:cNvPr id="4" name="Google-Shape-2260-p159-5">
             <a:extLst xmlns:a="http://schemas.openxmlformats.org/drawingml/2006/main">
               <a:ext uri="{FF2B5EF4-FFF2-40B4-BE49-F238E27FC236}">
-                <a16:creationId xmlns:a16="http://schemas.microsoft.com/office/drawing/2014/main" id="{FF023172-FCD7-40C7-8855-5129EC6D6C45}"/>
+                <a16:creationId xmlns:a16="http://schemas.microsoft.com/office/drawing/2014/main" id="{CA13BE0B-F7F2-4A78-AD06-A930A39658B6}"/>
               </a:ext>
             </a:extLst>
           </p:cNvPr>
@@ -2947,7 +2947,7 @@
           <p:cNvPr id="5" name="Google-Shape-2261-p159-6">
             <a:extLst xmlns:a="http://schemas.openxmlformats.org/drawingml/2006/main">
               <a:ext uri="{FF2B5EF4-FFF2-40B4-BE49-F238E27FC236}">
-                <a16:creationId xmlns:a16="http://schemas.microsoft.com/office/drawing/2014/main" id="{6530371D-AADD-4A56-ADD0-13E5FABC8760}"/>
+                <a16:creationId xmlns:a16="http://schemas.microsoft.com/office/drawing/2014/main" id="{99C712CB-AFDE-4354-A47A-545934710B73}"/>
               </a:ext>
             </a:extLst>
           </p:cNvPr>
@@ -2974,7 +2974,7 @@
           <p:cNvPr id="6" name="Google-Shape-2262-p159-7">
             <a:extLst xmlns:a="http://schemas.openxmlformats.org/drawingml/2006/main">
               <a:ext uri="{FF2B5EF4-FFF2-40B4-BE49-F238E27FC236}">
-                <a16:creationId xmlns:a16="http://schemas.microsoft.com/office/drawing/2014/main" id="{585FE42A-FB55-46E9-90F0-9DFA6B584C1C}"/>
+                <a16:creationId xmlns:a16="http://schemas.microsoft.com/office/drawing/2014/main" id="{8A9EEF51-10E7-47BB-B0F9-20071399E4FD}"/>
               </a:ext>
             </a:extLst>
           </p:cNvPr>
@@ -3001,7 +3001,7 @@
           <p:cNvPr id="7" name="Content-Placeholder-15-8">
             <a:extLst xmlns:a="http://schemas.openxmlformats.org/drawingml/2006/main">
               <a:ext uri="{FF2B5EF4-FFF2-40B4-BE49-F238E27FC236}">
-                <a16:creationId xmlns:a16="http://schemas.microsoft.com/office/drawing/2014/main" id="{EA403FB8-FF78-4526-B213-E5034D506F26}"/>
+                <a16:creationId xmlns:a16="http://schemas.microsoft.com/office/drawing/2014/main" id="{B4A6265A-CD5A-49A5-81F0-356DC39E987E}"/>
               </a:ext>
             </a:extLst>
           </p:cNvPr>
@@ -3058,7 +3058,7 @@
           <p:cNvPr id="8" name="Content-Placeholder-15-9">
             <a:extLst xmlns:a="http://schemas.openxmlformats.org/drawingml/2006/main">
               <a:ext uri="{FF2B5EF4-FFF2-40B4-BE49-F238E27FC236}">
-                <a16:creationId xmlns:a16="http://schemas.microsoft.com/office/drawing/2014/main" id="{C80F55CB-8776-478A-8416-80EB753FF3EF}"/>
+                <a16:creationId xmlns:a16="http://schemas.microsoft.com/office/drawing/2014/main" id="{24B7189D-775D-49D7-B097-5169C1E0484D}"/>
               </a:ext>
             </a:extLst>
           </p:cNvPr>
@@ -3115,7 +3115,7 @@
           <p:cNvPr id="9" name="Content-Placeholder-15-10">
             <a:extLst xmlns:a="http://schemas.openxmlformats.org/drawingml/2006/main">
               <a:ext uri="{FF2B5EF4-FFF2-40B4-BE49-F238E27FC236}">
-                <a16:creationId xmlns:a16="http://schemas.microsoft.com/office/drawing/2014/main" id="{149166C3-45B0-4556-92B3-9FA4B723C460}"/>
+                <a16:creationId xmlns:a16="http://schemas.microsoft.com/office/drawing/2014/main" id="{48223E1F-B5EF-4AA9-8304-6D90EB3B2C04}"/>
               </a:ext>
             </a:extLst>
           </p:cNvPr>
@@ -3172,7 +3172,7 @@
           <p:cNvPr id="10" name="Text-Placeholder-16-11">
             <a:extLst xmlns:a="http://schemas.openxmlformats.org/drawingml/2006/main">
               <a:ext uri="{FF2B5EF4-FFF2-40B4-BE49-F238E27FC236}">
-                <a16:creationId xmlns:a16="http://schemas.microsoft.com/office/drawing/2014/main" id="{73F39A0A-1E12-44B1-A35B-EA572A88C9D8}"/>
+                <a16:creationId xmlns:a16="http://schemas.microsoft.com/office/drawing/2014/main" id="{77830C17-04AF-40CE-BB5B-A198600FC110}"/>
               </a:ext>
             </a:extLst>
           </p:cNvPr>
@@ -3257,7 +3257,7 @@
           <p:cNvPr id="11" name="Text-Placeholder-16-12">
             <a:extLst xmlns:a="http://schemas.openxmlformats.org/drawingml/2006/main">
               <a:ext uri="{FF2B5EF4-FFF2-40B4-BE49-F238E27FC236}">
-                <a16:creationId xmlns:a16="http://schemas.microsoft.com/office/drawing/2014/main" id="{CEBAC02A-402B-454C-B1F0-ECE935DBFFC8}"/>
+                <a16:creationId xmlns:a16="http://schemas.microsoft.com/office/drawing/2014/main" id="{8E6B24DF-E0CA-4242-87BB-B83296FEC092}"/>
               </a:ext>
             </a:extLst>
           </p:cNvPr>
@@ -3342,7 +3342,7 @@
           <p:cNvPr id="12" name="Text-Placeholder-16-13">
             <a:extLst xmlns:a="http://schemas.openxmlformats.org/drawingml/2006/main">
               <a:ext uri="{FF2B5EF4-FFF2-40B4-BE49-F238E27FC236}">
-                <a16:creationId xmlns:a16="http://schemas.microsoft.com/office/drawing/2014/main" id="{F35E3015-8684-4D7B-BCA5-A687E25EE38E}"/>
+                <a16:creationId xmlns:a16="http://schemas.microsoft.com/office/drawing/2014/main" id="{DD0B6CA6-3760-4927-BFF7-8D46E9F50C6F}"/>
               </a:ext>
             </a:extLst>
           </p:cNvPr>
@@ -3425,7 +3425,7 @@
     </p:spTree>
     <p:extLst>
       <p:ext uri="{BB962C8B-B14F-4D97-AF65-F5344CB8AC3E}">
-        <p14:creationId xmlns:p14="http://schemas.microsoft.com/office/powerpoint/2010/main" val="188325070"/>
+        <p14:creationId xmlns:p14="http://schemas.microsoft.com/office/powerpoint/2010/main" val="399067223"/>
       </p:ext>
     </p:extLst>
   </p:cSld>
@@ -3449,7 +3449,7 @@
           <p:cNvPr id="6" name="Google-Shape-532-p58-2">
             <a:extLst xmlns:a="http://schemas.openxmlformats.org/drawingml/2006/main">
               <a:ext uri="{FF2B5EF4-FFF2-40B4-BE49-F238E27FC236}">
-                <a16:creationId xmlns:a16="http://schemas.microsoft.com/office/drawing/2014/main" id="{9B366904-D361-4C18-BE4C-B84D4AE875A6}"/>
+                <a16:creationId xmlns:a16="http://schemas.microsoft.com/office/drawing/2014/main" id="{EA28B9D6-C03D-41A6-8885-79FCD5C24B8B}"/>
               </a:ext>
             </a:extLst>
           </p:cNvPr>
@@ -3506,7 +3506,7 @@
           <p:cNvPr id="2" name="Google-Shape-533-p58-3">
             <a:extLst xmlns:a="http://schemas.openxmlformats.org/drawingml/2006/main">
               <a:ext uri="{FF2B5EF4-FFF2-40B4-BE49-F238E27FC236}">
-                <a16:creationId xmlns:a16="http://schemas.microsoft.com/office/drawing/2014/main" id="{39A869CF-2314-4E45-A4BC-4C20015D6026}"/>
+                <a16:creationId xmlns:a16="http://schemas.microsoft.com/office/drawing/2014/main" id="{6056D29F-DC2C-479F-99F6-0B0066CD692C}"/>
               </a:ext>
             </a:extLst>
           </p:cNvPr>
@@ -3563,7 +3563,7 @@
           <p:cNvPr id="3" name="Picture-3-4-backing">
             <a:extLst xmlns:a="http://schemas.openxmlformats.org/drawingml/2006/main">
               <a:ext uri="{FF2B5EF4-FFF2-40B4-BE49-F238E27FC236}">
-                <a16:creationId xmlns:a16="http://schemas.microsoft.com/office/drawing/2014/main" id="{89EF4EE4-7F76-4DD6-867C-933CBD0CD643}"/>
+                <a16:creationId xmlns:a16="http://schemas.microsoft.com/office/drawing/2014/main" id="{1EEF7F6D-F563-4BFA-BE22-0B017BF224B8}"/>
               </a:ext>
             </a:extLst>
           </p:cNvPr>
@@ -3602,7 +3602,7 @@
           <p:nvPr/>
         </p:nvPicPr>
         <p:blipFill>
-          <a:blip xmlns:r="http://schemas.openxmlformats.org/officeDocument/2006/relationships" xmlns:a="http://schemas.openxmlformats.org/drawingml/2006/main" r:embed="Re121e76c0b824bff"/>
+          <a:blip xmlns:r="http://schemas.openxmlformats.org/officeDocument/2006/relationships" xmlns:a="http://schemas.openxmlformats.org/drawingml/2006/main" r:embed="Rbfc229e167514d0b"/>
           <a:srcRect xmlns:a="http://schemas.openxmlformats.org/drawingml/2006/main" l="0" t="16639" r="0" b="16639"/>
           <a:stretch xmlns:a="http://schemas.openxmlformats.org/drawingml/2006/main">
             <a:fillRect l="0" t="0" r="0" b="0"/>
@@ -3623,7 +3623,7 @@
           <p:cNvPr id="5" name="Google-Shape-534-p58-5">
             <a:extLst xmlns:a="http://schemas.openxmlformats.org/drawingml/2006/main">
               <a:ext uri="{FF2B5EF4-FFF2-40B4-BE49-F238E27FC236}">
-                <a16:creationId xmlns:a16="http://schemas.microsoft.com/office/drawing/2014/main" id="{4E388493-5E92-4CDC-A4E9-74A96365C0DE}"/>
+                <a16:creationId xmlns:a16="http://schemas.microsoft.com/office/drawing/2014/main" id="{0AD89944-DA04-47B9-AB45-5559EC1B1C72}"/>
               </a:ext>
             </a:extLst>
           </p:cNvPr>
@@ -3709,7 +3709,7 @@
     </p:spTree>
     <p:extLst>
       <p:ext uri="{BB962C8B-B14F-4D97-AF65-F5344CB8AC3E}">
-        <p14:creationId xmlns:p14="http://schemas.microsoft.com/office/powerpoint/2010/main" val="1684872557"/>
+        <p14:creationId xmlns:p14="http://schemas.microsoft.com/office/powerpoint/2010/main" val="245066006"/>
       </p:ext>
     </p:extLst>
   </p:cSld>
@@ -3733,7 +3733,7 @@
           <p:cNvPr id="13" name="Rounded-Rectangle-5-1">
             <a:extLst xmlns:a="http://schemas.openxmlformats.org/drawingml/2006/main">
               <a:ext uri="{FF2B5EF4-FFF2-40B4-BE49-F238E27FC236}">
-                <a16:creationId xmlns:a16="http://schemas.microsoft.com/office/drawing/2014/main" id="{56423A05-D7AE-4700-9CA2-0E186933E9DD}"/>
+                <a16:creationId xmlns:a16="http://schemas.microsoft.com/office/drawing/2014/main" id="{E4C12471-DC12-4A06-ACBA-FB09056AADA0}"/>
               </a:ext>
             </a:extLst>
           </p:cNvPr>
@@ -3762,7 +3762,7 @@
           <p:cNvPr id="2" name="Rounded-Rectangle-6-2">
             <a:extLst xmlns:a="http://schemas.openxmlformats.org/drawingml/2006/main">
               <a:ext uri="{FF2B5EF4-FFF2-40B4-BE49-F238E27FC236}">
-                <a16:creationId xmlns:a16="http://schemas.microsoft.com/office/drawing/2014/main" id="{E078926B-F15D-4DDE-AA36-2E11429CBAB6}"/>
+                <a16:creationId xmlns:a16="http://schemas.microsoft.com/office/drawing/2014/main" id="{DE1C429B-E8AD-4535-B2D3-11FF676D46FE}"/>
               </a:ext>
             </a:extLst>
           </p:cNvPr>
@@ -3791,7 +3791,7 @@
           <p:cNvPr id="3" name="Rounded-Rectangle-7-3">
             <a:extLst xmlns:a="http://schemas.openxmlformats.org/drawingml/2006/main">
               <a:ext uri="{FF2B5EF4-FFF2-40B4-BE49-F238E27FC236}">
-                <a16:creationId xmlns:a16="http://schemas.microsoft.com/office/drawing/2014/main" id="{E735682B-BD0D-462D-B8C2-487BF6158902}"/>
+                <a16:creationId xmlns:a16="http://schemas.microsoft.com/office/drawing/2014/main" id="{C83936BB-FFD9-48FC-AFA2-6656C7EB109D}"/>
               </a:ext>
             </a:extLst>
           </p:cNvPr>
@@ -3820,7 +3820,7 @@
           <p:cNvPr id="4" name="Slide-Number-Placeholder-1-4">
             <a:extLst xmlns:a="http://schemas.openxmlformats.org/drawingml/2006/main">
               <a:ext uri="{FF2B5EF4-FFF2-40B4-BE49-F238E27FC236}">
-                <a16:creationId xmlns:a16="http://schemas.microsoft.com/office/drawing/2014/main" id="{5CFA981F-8DD3-424F-9010-54D5B9091DED}"/>
+                <a16:creationId xmlns:a16="http://schemas.microsoft.com/office/drawing/2014/main" id="{7AC54E26-9F9D-40D0-ADC3-1E8669456028}"/>
               </a:ext>
             </a:extLst>
           </p:cNvPr>
@@ -3875,7 +3875,7 @@
           <p:cNvPr id="5" name="Title-2-5">
             <a:extLst xmlns:a="http://schemas.openxmlformats.org/drawingml/2006/main">
               <a:ext uri="{FF2B5EF4-FFF2-40B4-BE49-F238E27FC236}">
-                <a16:creationId xmlns:a16="http://schemas.microsoft.com/office/drawing/2014/main" id="{94F0E775-A728-4040-A8FD-C09FD1A12491}"/>
+                <a16:creationId xmlns:a16="http://schemas.microsoft.com/office/drawing/2014/main" id="{C2112DDF-920D-47D3-A7EC-6EAAF00F1637}"/>
               </a:ext>
             </a:extLst>
           </p:cNvPr>
@@ -3932,7 +3932,7 @@
           <p:cNvPr id="6" name="Content-Placeholder-9-6">
             <a:extLst xmlns:a="http://schemas.openxmlformats.org/drawingml/2006/main">
               <a:ext uri="{FF2B5EF4-FFF2-40B4-BE49-F238E27FC236}">
-                <a16:creationId xmlns:a16="http://schemas.microsoft.com/office/drawing/2014/main" id="{670CDDB2-4B1A-40D3-8154-DEF220B8E20F}"/>
+                <a16:creationId xmlns:a16="http://schemas.microsoft.com/office/drawing/2014/main" id="{C412ED65-9E99-4DB8-9C37-99F8BF512FB9}"/>
               </a:ext>
             </a:extLst>
           </p:cNvPr>
@@ -3990,7 +3990,7 @@
           <p:cNvPr id="7" name="Content-Placeholder-10-7">
             <a:extLst xmlns:a="http://schemas.openxmlformats.org/drawingml/2006/main">
               <a:ext uri="{FF2B5EF4-FFF2-40B4-BE49-F238E27FC236}">
-                <a16:creationId xmlns:a16="http://schemas.microsoft.com/office/drawing/2014/main" id="{FD90AF39-FCD9-4F30-B292-A9DD93FE2147}"/>
+                <a16:creationId xmlns:a16="http://schemas.microsoft.com/office/drawing/2014/main" id="{80513AB1-041F-4CAD-9FA1-8BAF05FA834A}"/>
               </a:ext>
             </a:extLst>
           </p:cNvPr>
@@ -4048,7 +4048,7 @@
           <p:cNvPr id="8" name="Content-Placeholder-11-8">
             <a:extLst xmlns:a="http://schemas.openxmlformats.org/drawingml/2006/main">
               <a:ext uri="{FF2B5EF4-FFF2-40B4-BE49-F238E27FC236}">
-                <a16:creationId xmlns:a16="http://schemas.microsoft.com/office/drawing/2014/main" id="{7FDEFAB0-400F-43F9-B461-4CE5FF7FEBB9}"/>
+                <a16:creationId xmlns:a16="http://schemas.microsoft.com/office/drawing/2014/main" id="{89F6CC66-90C7-425A-B3DA-66A0C67288D4}"/>
               </a:ext>
             </a:extLst>
           </p:cNvPr>
@@ -4106,7 +4106,7 @@
           <p:cNvPr id="9" name="Content-Placeholder-9-9">
             <a:extLst xmlns:a="http://schemas.openxmlformats.org/drawingml/2006/main">
               <a:ext uri="{FF2B5EF4-FFF2-40B4-BE49-F238E27FC236}">
-                <a16:creationId xmlns:a16="http://schemas.microsoft.com/office/drawing/2014/main" id="{BACBAA56-89C2-457E-A5BE-B1B1AA41D89D}"/>
+                <a16:creationId xmlns:a16="http://schemas.microsoft.com/office/drawing/2014/main" id="{16457A67-9A34-4EA4-A678-63FB65E15ED3}"/>
               </a:ext>
             </a:extLst>
           </p:cNvPr>
@@ -4163,7 +4163,7 @@
           <p:cNvPr id="10" name="Content-Placeholder-9-10">
             <a:extLst xmlns:a="http://schemas.openxmlformats.org/drawingml/2006/main">
               <a:ext uri="{FF2B5EF4-FFF2-40B4-BE49-F238E27FC236}">
-                <a16:creationId xmlns:a16="http://schemas.microsoft.com/office/drawing/2014/main" id="{54C90311-B00B-4E01-97B7-6F35EA1A2C6B}"/>
+                <a16:creationId xmlns:a16="http://schemas.microsoft.com/office/drawing/2014/main" id="{637037A0-9BCC-41D4-A6F4-0B5772AA727B}"/>
               </a:ext>
             </a:extLst>
           </p:cNvPr>
@@ -4220,7 +4220,7 @@
           <p:cNvPr id="11" name="Content-Placeholder-9-11">
             <a:extLst xmlns:a="http://schemas.openxmlformats.org/drawingml/2006/main">
               <a:ext uri="{FF2B5EF4-FFF2-40B4-BE49-F238E27FC236}">
-                <a16:creationId xmlns:a16="http://schemas.microsoft.com/office/drawing/2014/main" id="{41BD1BDC-5A13-45C9-A9E6-3B74E58231D7}"/>
+                <a16:creationId xmlns:a16="http://schemas.microsoft.com/office/drawing/2014/main" id="{F295B3B2-8E3E-40F8-98D6-E8BE0438DD32}"/>
               </a:ext>
             </a:extLst>
           </p:cNvPr>
@@ -4277,7 +4277,7 @@
           <p:cNvPr id="12" name="Content-Placeholder-15-12">
             <a:extLst xmlns:a="http://schemas.openxmlformats.org/drawingml/2006/main">
               <a:ext uri="{FF2B5EF4-FFF2-40B4-BE49-F238E27FC236}">
-                <a16:creationId xmlns:a16="http://schemas.microsoft.com/office/drawing/2014/main" id="{6D5723CE-A1F2-494C-88E7-086B15FC2283}"/>
+                <a16:creationId xmlns:a16="http://schemas.microsoft.com/office/drawing/2014/main" id="{1C0104C3-CEBB-4EDD-9130-FDC3D632F926}"/>
               </a:ext>
             </a:extLst>
           </p:cNvPr>
@@ -4359,7 +4359,7 @@
     </p:spTree>
     <p:extLst>
       <p:ext uri="{BB962C8B-B14F-4D97-AF65-F5344CB8AC3E}">
-        <p14:creationId xmlns:p14="http://schemas.microsoft.com/office/powerpoint/2010/main" val="2006489136"/>
+        <p14:creationId xmlns:p14="http://schemas.microsoft.com/office/powerpoint/2010/main" val="686927970"/>
       </p:ext>
     </p:extLst>
   </p:cSld>
@@ -4383,7 +4383,7 @@
           <p:cNvPr id="6" name="Google-Shape-532-p58-2">
             <a:extLst xmlns:a="http://schemas.openxmlformats.org/drawingml/2006/main">
               <a:ext uri="{FF2B5EF4-FFF2-40B4-BE49-F238E27FC236}">
-                <a16:creationId xmlns:a16="http://schemas.microsoft.com/office/drawing/2014/main" id="{9ED2C74D-78CF-46AD-A321-6A9D105708E9}"/>
+                <a16:creationId xmlns:a16="http://schemas.microsoft.com/office/drawing/2014/main" id="{DAFF72BF-E7D4-4599-9151-EE38B9D9C726}"/>
               </a:ext>
             </a:extLst>
           </p:cNvPr>
@@ -4440,7 +4440,7 @@
           <p:cNvPr id="2" name="Google-Shape-533-p58-3">
             <a:extLst xmlns:a="http://schemas.openxmlformats.org/drawingml/2006/main">
               <a:ext uri="{FF2B5EF4-FFF2-40B4-BE49-F238E27FC236}">
-                <a16:creationId xmlns:a16="http://schemas.microsoft.com/office/drawing/2014/main" id="{CDA4D034-7313-4118-9674-302332857A14}"/>
+                <a16:creationId xmlns:a16="http://schemas.microsoft.com/office/drawing/2014/main" id="{32A79465-E8D0-4274-9898-D1A2509F5678}"/>
               </a:ext>
             </a:extLst>
           </p:cNvPr>
@@ -4497,7 +4497,7 @@
           <p:cNvPr id="3" name="Picture-3-4-backing">
             <a:extLst xmlns:a="http://schemas.openxmlformats.org/drawingml/2006/main">
               <a:ext uri="{FF2B5EF4-FFF2-40B4-BE49-F238E27FC236}">
-                <a16:creationId xmlns:a16="http://schemas.microsoft.com/office/drawing/2014/main" id="{6397209D-9983-4AA0-B7D1-6812ECB9A410}"/>
+                <a16:creationId xmlns:a16="http://schemas.microsoft.com/office/drawing/2014/main" id="{0A3BD027-DE51-4683-8D6B-7B17655F1C47}"/>
               </a:ext>
             </a:extLst>
           </p:cNvPr>
@@ -4536,7 +4536,7 @@
           <p:nvPr/>
         </p:nvPicPr>
         <p:blipFill>
-          <a:blip xmlns:r="http://schemas.openxmlformats.org/officeDocument/2006/relationships" xmlns:a="http://schemas.openxmlformats.org/drawingml/2006/main" r:embed="Rb80604ffa2874509"/>
+          <a:blip xmlns:r="http://schemas.openxmlformats.org/officeDocument/2006/relationships" xmlns:a="http://schemas.openxmlformats.org/drawingml/2006/main" r:embed="R620cebbe43a24001"/>
           <a:srcRect xmlns:a="http://schemas.openxmlformats.org/drawingml/2006/main" l="8158" t="0" r="8158" b="0"/>
           <a:stretch xmlns:a="http://schemas.openxmlformats.org/drawingml/2006/main">
             <a:fillRect l="0" t="0" r="0" b="0"/>
@@ -4557,7 +4557,7 @@
           <p:cNvPr id="5" name="Google-Shape-534-p58-5">
             <a:extLst xmlns:a="http://schemas.openxmlformats.org/drawingml/2006/main">
               <a:ext uri="{FF2B5EF4-FFF2-40B4-BE49-F238E27FC236}">
-                <a16:creationId xmlns:a16="http://schemas.microsoft.com/office/drawing/2014/main" id="{F4447DB6-8223-4044-BF5F-BA86BD147394}"/>
+                <a16:creationId xmlns:a16="http://schemas.microsoft.com/office/drawing/2014/main" id="{997329E7-A9AA-414F-9A88-EF4FAD3B3986}"/>
               </a:ext>
             </a:extLst>
           </p:cNvPr>
@@ -4641,7 +4641,7 @@
     </p:spTree>
     <p:extLst>
       <p:ext uri="{BB962C8B-B14F-4D97-AF65-F5344CB8AC3E}">
-        <p14:creationId xmlns:p14="http://schemas.microsoft.com/office/powerpoint/2010/main" val="209947454"/>
+        <p14:creationId xmlns:p14="http://schemas.microsoft.com/office/powerpoint/2010/main" val="1923934376"/>
       </p:ext>
     </p:extLst>
   </p:cSld>
@@ -4665,7 +4665,7 @@
           <p:cNvPr id="13" name="Rounded-Rectangle-5-1">
             <a:extLst xmlns:a="http://schemas.openxmlformats.org/drawingml/2006/main">
               <a:ext uri="{FF2B5EF4-FFF2-40B4-BE49-F238E27FC236}">
-                <a16:creationId xmlns:a16="http://schemas.microsoft.com/office/drawing/2014/main" id="{AA0ABBB8-4AD8-426E-89E7-2E8CFBDCA21C}"/>
+                <a16:creationId xmlns:a16="http://schemas.microsoft.com/office/drawing/2014/main" id="{0728060C-5C45-4A35-97F2-A5B0D79B4C6D}"/>
               </a:ext>
             </a:extLst>
           </p:cNvPr>
@@ -4694,7 +4694,7 @@
           <p:cNvPr id="2" name="Rounded-Rectangle-6-2">
             <a:extLst xmlns:a="http://schemas.openxmlformats.org/drawingml/2006/main">
               <a:ext uri="{FF2B5EF4-FFF2-40B4-BE49-F238E27FC236}">
-                <a16:creationId xmlns:a16="http://schemas.microsoft.com/office/drawing/2014/main" id="{4B474782-5D6C-4368-B0A0-B434331E7831}"/>
+                <a16:creationId xmlns:a16="http://schemas.microsoft.com/office/drawing/2014/main" id="{D58030DA-533F-488C-B53E-61DE4137BEFB}"/>
               </a:ext>
             </a:extLst>
           </p:cNvPr>
@@ -4723,7 +4723,7 @@
           <p:cNvPr id="3" name="Rounded-Rectangle-7-3">
             <a:extLst xmlns:a="http://schemas.openxmlformats.org/drawingml/2006/main">
               <a:ext uri="{FF2B5EF4-FFF2-40B4-BE49-F238E27FC236}">
-                <a16:creationId xmlns:a16="http://schemas.microsoft.com/office/drawing/2014/main" id="{C5E42DA8-A1F2-49CF-A303-E80911872240}"/>
+                <a16:creationId xmlns:a16="http://schemas.microsoft.com/office/drawing/2014/main" id="{B1C7D5C5-A1B9-405B-B6D5-F12667B7AC3A}"/>
               </a:ext>
             </a:extLst>
           </p:cNvPr>
@@ -4752,7 +4752,7 @@
           <p:cNvPr id="4" name="Slide-Number-Placeholder-1-4">
             <a:extLst xmlns:a="http://schemas.openxmlformats.org/drawingml/2006/main">
               <a:ext uri="{FF2B5EF4-FFF2-40B4-BE49-F238E27FC236}">
-                <a16:creationId xmlns:a16="http://schemas.microsoft.com/office/drawing/2014/main" id="{8EEE05E2-6B53-4876-B147-E255158FACCD}"/>
+                <a16:creationId xmlns:a16="http://schemas.microsoft.com/office/drawing/2014/main" id="{77E2959C-BE46-483A-94DC-0AA6D0567E07}"/>
               </a:ext>
             </a:extLst>
           </p:cNvPr>
@@ -4807,7 +4807,7 @@
           <p:cNvPr id="5" name="Title-2-5">
             <a:extLst xmlns:a="http://schemas.openxmlformats.org/drawingml/2006/main">
               <a:ext uri="{FF2B5EF4-FFF2-40B4-BE49-F238E27FC236}">
-                <a16:creationId xmlns:a16="http://schemas.microsoft.com/office/drawing/2014/main" id="{AA82EB4E-72E6-4BFE-8192-F40A781D5856}"/>
+                <a16:creationId xmlns:a16="http://schemas.microsoft.com/office/drawing/2014/main" id="{21FD5D9D-8673-4252-BCFA-7E3147F84F75}"/>
               </a:ext>
             </a:extLst>
           </p:cNvPr>
@@ -4864,7 +4864,7 @@
           <p:cNvPr id="6" name="Content-Placeholder-9-6">
             <a:extLst xmlns:a="http://schemas.openxmlformats.org/drawingml/2006/main">
               <a:ext uri="{FF2B5EF4-FFF2-40B4-BE49-F238E27FC236}">
-                <a16:creationId xmlns:a16="http://schemas.microsoft.com/office/drawing/2014/main" id="{D6DB8D1E-E2B7-4CAC-8C33-91C10B5DF9BA}"/>
+                <a16:creationId xmlns:a16="http://schemas.microsoft.com/office/drawing/2014/main" id="{0DE6A18B-D3B5-47EC-ADA6-99C17B8A7554}"/>
               </a:ext>
             </a:extLst>
           </p:cNvPr>
@@ -4922,7 +4922,7 @@
           <p:cNvPr id="7" name="Content-Placeholder-10-7">
             <a:extLst xmlns:a="http://schemas.openxmlformats.org/drawingml/2006/main">
               <a:ext uri="{FF2B5EF4-FFF2-40B4-BE49-F238E27FC236}">
-                <a16:creationId xmlns:a16="http://schemas.microsoft.com/office/drawing/2014/main" id="{FA8AFA82-9871-4AEE-90D5-08917354D1D2}"/>
+                <a16:creationId xmlns:a16="http://schemas.microsoft.com/office/drawing/2014/main" id="{55ED98F6-4549-4E24-BC82-EB0B0B8F15C8}"/>
               </a:ext>
             </a:extLst>
           </p:cNvPr>
@@ -4980,7 +4980,7 @@
           <p:cNvPr id="8" name="Content-Placeholder-11-8">
             <a:extLst xmlns:a="http://schemas.openxmlformats.org/drawingml/2006/main">
               <a:ext uri="{FF2B5EF4-FFF2-40B4-BE49-F238E27FC236}">
-                <a16:creationId xmlns:a16="http://schemas.microsoft.com/office/drawing/2014/main" id="{06889D98-EEC4-4DF2-B593-D878724398C4}"/>
+                <a16:creationId xmlns:a16="http://schemas.microsoft.com/office/drawing/2014/main" id="{25D85DEF-CF4C-487E-B872-0C22E2EB0D3C}"/>
               </a:ext>
             </a:extLst>
           </p:cNvPr>
@@ -5038,7 +5038,7 @@
           <p:cNvPr id="9" name="Content-Placeholder-9-9">
             <a:extLst xmlns:a="http://schemas.openxmlformats.org/drawingml/2006/main">
               <a:ext uri="{FF2B5EF4-FFF2-40B4-BE49-F238E27FC236}">
-                <a16:creationId xmlns:a16="http://schemas.microsoft.com/office/drawing/2014/main" id="{9D37D30E-F800-4078-927B-9C71BC18CA6F}"/>
+                <a16:creationId xmlns:a16="http://schemas.microsoft.com/office/drawing/2014/main" id="{5C3456BB-5BD3-4424-A258-5FB3AF593199}"/>
               </a:ext>
             </a:extLst>
           </p:cNvPr>
@@ -5095,7 +5095,7 @@
           <p:cNvPr id="10" name="Content-Placeholder-9-10">
             <a:extLst xmlns:a="http://schemas.openxmlformats.org/drawingml/2006/main">
               <a:ext uri="{FF2B5EF4-FFF2-40B4-BE49-F238E27FC236}">
-                <a16:creationId xmlns:a16="http://schemas.microsoft.com/office/drawing/2014/main" id="{D7C80D3C-5FB8-4C80-B03D-09BB5556C501}"/>
+                <a16:creationId xmlns:a16="http://schemas.microsoft.com/office/drawing/2014/main" id="{421653EB-D411-46D0-A1E2-2698434A33D8}"/>
               </a:ext>
             </a:extLst>
           </p:cNvPr>
@@ -5152,7 +5152,7 @@
           <p:cNvPr id="11" name="Content-Placeholder-9-11">
             <a:extLst xmlns:a="http://schemas.openxmlformats.org/drawingml/2006/main">
               <a:ext uri="{FF2B5EF4-FFF2-40B4-BE49-F238E27FC236}">
-                <a16:creationId xmlns:a16="http://schemas.microsoft.com/office/drawing/2014/main" id="{62370230-E5F2-4873-A4A0-851494A43BFB}"/>
+                <a16:creationId xmlns:a16="http://schemas.microsoft.com/office/drawing/2014/main" id="{53534A2F-529D-446D-AB56-CEA057F95C31}"/>
               </a:ext>
             </a:extLst>
           </p:cNvPr>
@@ -5209,7 +5209,7 @@
           <p:cNvPr id="12" name="Content-Placeholder-15-12">
             <a:extLst xmlns:a="http://schemas.openxmlformats.org/drawingml/2006/main">
               <a:ext uri="{FF2B5EF4-FFF2-40B4-BE49-F238E27FC236}">
-                <a16:creationId xmlns:a16="http://schemas.microsoft.com/office/drawing/2014/main" id="{71696B09-411A-4D94-82E7-34877572583C}"/>
+                <a16:creationId xmlns:a16="http://schemas.microsoft.com/office/drawing/2014/main" id="{2621B5C5-CE1E-48EA-AC4D-63BE556A7CA0}"/>
               </a:ext>
             </a:extLst>
           </p:cNvPr>
@@ -5291,7 +5291,7 @@
     </p:spTree>
     <p:extLst>
       <p:ext uri="{BB962C8B-B14F-4D97-AF65-F5344CB8AC3E}">
-        <p14:creationId xmlns:p14="http://schemas.microsoft.com/office/powerpoint/2010/main" val="1649161777"/>
+        <p14:creationId xmlns:p14="http://schemas.microsoft.com/office/powerpoint/2010/main" val="97200575"/>
       </p:ext>
     </p:extLst>
   </p:cSld>
@@ -5315,7 +5315,7 @@
           <p:cNvPr id="6" name="Google-Shape-532-p58-2">
             <a:extLst xmlns:a="http://schemas.openxmlformats.org/drawingml/2006/main">
               <a:ext uri="{FF2B5EF4-FFF2-40B4-BE49-F238E27FC236}">
-                <a16:creationId xmlns:a16="http://schemas.microsoft.com/office/drawing/2014/main" id="{CC846066-D1CD-460C-87F1-891848CFF0BD}"/>
+                <a16:creationId xmlns:a16="http://schemas.microsoft.com/office/drawing/2014/main" id="{FB5D38BB-F42E-4707-9ACB-86D0D7727490}"/>
               </a:ext>
             </a:extLst>
           </p:cNvPr>
@@ -5372,7 +5372,7 @@
           <p:cNvPr id="2" name="Google-Shape-533-p58-3">
             <a:extLst xmlns:a="http://schemas.openxmlformats.org/drawingml/2006/main">
               <a:ext uri="{FF2B5EF4-FFF2-40B4-BE49-F238E27FC236}">
-                <a16:creationId xmlns:a16="http://schemas.microsoft.com/office/drawing/2014/main" id="{4828B87E-EC15-4167-A792-D079B6BC315B}"/>
+                <a16:creationId xmlns:a16="http://schemas.microsoft.com/office/drawing/2014/main" id="{563E68BE-C42E-4199-8426-D750DE9C2BA8}"/>
               </a:ext>
             </a:extLst>
           </p:cNvPr>
@@ -5429,7 +5429,7 @@
           <p:cNvPr id="3" name="Google-Shape-534-p58-4">
             <a:extLst xmlns:a="http://schemas.openxmlformats.org/drawingml/2006/main">
               <a:ext uri="{FF2B5EF4-FFF2-40B4-BE49-F238E27FC236}">
-                <a16:creationId xmlns:a16="http://schemas.microsoft.com/office/drawing/2014/main" id="{6490447B-AB21-4214-8623-F0F6BE9EB618}"/>
+                <a16:creationId xmlns:a16="http://schemas.microsoft.com/office/drawing/2014/main" id="{03AE177F-7A8D-4B9F-A13A-81ACCC5D9960}"/>
               </a:ext>
             </a:extLst>
           </p:cNvPr>
@@ -5514,7 +5514,7 @@
           <p:cNvPr id="4" name="Content-Placeholder-1-5">
             <a:extLst xmlns:a="http://schemas.openxmlformats.org/drawingml/2006/main">
               <a:ext uri="{FF2B5EF4-FFF2-40B4-BE49-F238E27FC236}">
-                <a16:creationId xmlns:a16="http://schemas.microsoft.com/office/drawing/2014/main" id="{2723EB4A-CB0C-4F71-96BB-44C5ADC3990C}"/>
+                <a16:creationId xmlns:a16="http://schemas.microsoft.com/office/drawing/2014/main" id="{5DBC4959-6848-4472-B7FA-5EEE686AD33E}"/>
               </a:ext>
             </a:extLst>
           </p:cNvPr>
@@ -5599,7 +5599,7 @@
           <p:cNvPr id="5" name="Content-Placeholder-2-6">
             <a:extLst xmlns:a="http://schemas.openxmlformats.org/drawingml/2006/main">
               <a:ext uri="{FF2B5EF4-FFF2-40B4-BE49-F238E27FC236}">
-                <a16:creationId xmlns:a16="http://schemas.microsoft.com/office/drawing/2014/main" id="{959D219F-319B-441A-83DB-88D5192834B5}"/>
+                <a16:creationId xmlns:a16="http://schemas.microsoft.com/office/drawing/2014/main" id="{76C0A717-811A-4064-A857-751C88740703}"/>
               </a:ext>
             </a:extLst>
           </p:cNvPr>
@@ -5682,7 +5682,7 @@
     </p:spTree>
     <p:extLst>
       <p:ext uri="{BB962C8B-B14F-4D97-AF65-F5344CB8AC3E}">
-        <p14:creationId xmlns:p14="http://schemas.microsoft.com/office/powerpoint/2010/main" val="1282723652"/>
+        <p14:creationId xmlns:p14="http://schemas.microsoft.com/office/powerpoint/2010/main" val="1764378683"/>
       </p:ext>
     </p:extLst>
   </p:cSld>
@@ -5706,7 +5706,7 @@
           <p:cNvPr id="13" name="Rounded-Rectangle-5-1">
             <a:extLst xmlns:a="http://schemas.openxmlformats.org/drawingml/2006/main">
               <a:ext uri="{FF2B5EF4-FFF2-40B4-BE49-F238E27FC236}">
-                <a16:creationId xmlns:a16="http://schemas.microsoft.com/office/drawing/2014/main" id="{9F980494-755F-47D4-9657-35D03CB5502B}"/>
+                <a16:creationId xmlns:a16="http://schemas.microsoft.com/office/drawing/2014/main" id="{32F731F1-7A3B-4DCD-B6C2-7D1AADB0EE31}"/>
               </a:ext>
             </a:extLst>
           </p:cNvPr>
@@ -5735,7 +5735,7 @@
           <p:cNvPr id="2" name="Rounded-Rectangle-6-2">
             <a:extLst xmlns:a="http://schemas.openxmlformats.org/drawingml/2006/main">
               <a:ext uri="{FF2B5EF4-FFF2-40B4-BE49-F238E27FC236}">
-                <a16:creationId xmlns:a16="http://schemas.microsoft.com/office/drawing/2014/main" id="{6F35E27B-A524-4B00-A51B-A9A34702DD8F}"/>
+                <a16:creationId xmlns:a16="http://schemas.microsoft.com/office/drawing/2014/main" id="{47DE4F5F-8B1E-4F5E-85E6-BC2F02EE904F}"/>
               </a:ext>
             </a:extLst>
           </p:cNvPr>
@@ -5764,7 +5764,7 @@
           <p:cNvPr id="3" name="Rounded-Rectangle-7-3">
             <a:extLst xmlns:a="http://schemas.openxmlformats.org/drawingml/2006/main">
               <a:ext uri="{FF2B5EF4-FFF2-40B4-BE49-F238E27FC236}">
-                <a16:creationId xmlns:a16="http://schemas.microsoft.com/office/drawing/2014/main" id="{64FA3B12-DD91-4E41-BA49-940890F52F18}"/>
+                <a16:creationId xmlns:a16="http://schemas.microsoft.com/office/drawing/2014/main" id="{27A01497-B456-4ABF-AA4D-5DBA565428E9}"/>
               </a:ext>
             </a:extLst>
           </p:cNvPr>
@@ -5793,7 +5793,7 @@
           <p:cNvPr id="4" name="Slide-Number-Placeholder-1-4">
             <a:extLst xmlns:a="http://schemas.openxmlformats.org/drawingml/2006/main">
               <a:ext uri="{FF2B5EF4-FFF2-40B4-BE49-F238E27FC236}">
-                <a16:creationId xmlns:a16="http://schemas.microsoft.com/office/drawing/2014/main" id="{2A991862-21D1-48C7-9155-22EC36E88B71}"/>
+                <a16:creationId xmlns:a16="http://schemas.microsoft.com/office/drawing/2014/main" id="{C0AFCC84-3A0A-467B-9657-375C2749B26D}"/>
               </a:ext>
             </a:extLst>
           </p:cNvPr>
@@ -5848,7 +5848,7 @@
           <p:cNvPr id="5" name="Title-2-5">
             <a:extLst xmlns:a="http://schemas.openxmlformats.org/drawingml/2006/main">
               <a:ext uri="{FF2B5EF4-FFF2-40B4-BE49-F238E27FC236}">
-                <a16:creationId xmlns:a16="http://schemas.microsoft.com/office/drawing/2014/main" id="{2463B66D-DC2E-49DD-A7EB-C544A10ED19A}"/>
+                <a16:creationId xmlns:a16="http://schemas.microsoft.com/office/drawing/2014/main" id="{EE0BA869-0168-42D6-8E32-F9031C056FB0}"/>
               </a:ext>
             </a:extLst>
           </p:cNvPr>
@@ -5905,7 +5905,7 @@
           <p:cNvPr id="6" name="Content-Placeholder-9-6">
             <a:extLst xmlns:a="http://schemas.openxmlformats.org/drawingml/2006/main">
               <a:ext uri="{FF2B5EF4-FFF2-40B4-BE49-F238E27FC236}">
-                <a16:creationId xmlns:a16="http://schemas.microsoft.com/office/drawing/2014/main" id="{1A32340A-72E1-4E9E-9858-72CB340E4CB1}"/>
+                <a16:creationId xmlns:a16="http://schemas.microsoft.com/office/drawing/2014/main" id="{26C15053-3D85-4769-98C6-7AFD0AB7BA15}"/>
               </a:ext>
             </a:extLst>
           </p:cNvPr>
@@ -5963,7 +5963,7 @@
           <p:cNvPr id="7" name="Content-Placeholder-10-7">
             <a:extLst xmlns:a="http://schemas.openxmlformats.org/drawingml/2006/main">
               <a:ext uri="{FF2B5EF4-FFF2-40B4-BE49-F238E27FC236}">
-                <a16:creationId xmlns:a16="http://schemas.microsoft.com/office/drawing/2014/main" id="{C4C71552-7DAC-4DC1-BBCD-D38BB11AFA42}"/>
+                <a16:creationId xmlns:a16="http://schemas.microsoft.com/office/drawing/2014/main" id="{14C3EA56-CA96-4FDC-B2E4-7FD6BAB9213A}"/>
               </a:ext>
             </a:extLst>
           </p:cNvPr>
@@ -6021,7 +6021,7 @@
           <p:cNvPr id="8" name="Content-Placeholder-11-8">
             <a:extLst xmlns:a="http://schemas.openxmlformats.org/drawingml/2006/main">
               <a:ext uri="{FF2B5EF4-FFF2-40B4-BE49-F238E27FC236}">
-                <a16:creationId xmlns:a16="http://schemas.microsoft.com/office/drawing/2014/main" id="{AC087A66-BAA5-484C-A8A1-874373A9FD73}"/>
+                <a16:creationId xmlns:a16="http://schemas.microsoft.com/office/drawing/2014/main" id="{210B801E-36A1-46ED-BD15-4C14D855B373}"/>
               </a:ext>
             </a:extLst>
           </p:cNvPr>
@@ -6079,7 +6079,7 @@
           <p:cNvPr id="9" name="Content-Placeholder-9-9">
             <a:extLst xmlns:a="http://schemas.openxmlformats.org/drawingml/2006/main">
               <a:ext uri="{FF2B5EF4-FFF2-40B4-BE49-F238E27FC236}">
-                <a16:creationId xmlns:a16="http://schemas.microsoft.com/office/drawing/2014/main" id="{1B9DE586-F5FD-45F7-8E80-CD7BEA1610CD}"/>
+                <a16:creationId xmlns:a16="http://schemas.microsoft.com/office/drawing/2014/main" id="{A0877B0A-AD08-4424-A46A-E388D1246201}"/>
               </a:ext>
             </a:extLst>
           </p:cNvPr>
@@ -6126,7 +6126,7 @@
                 <a:ea typeface="Microsoft YaHei"/>
                 <a:cs typeface="Microsoft YaHei"/>
               </a:rPr>
-              <a:t>56/56</a:t>
+              <a:t>57/57</a:t>
             </a:r>
           </a:p>
         </p:txBody>
@@ -6136,7 +6136,7 @@
           <p:cNvPr id="10" name="Content-Placeholder-9-10">
             <a:extLst xmlns:a="http://schemas.openxmlformats.org/drawingml/2006/main">
               <a:ext uri="{FF2B5EF4-FFF2-40B4-BE49-F238E27FC236}">
-                <a16:creationId xmlns:a16="http://schemas.microsoft.com/office/drawing/2014/main" id="{882BF625-5F18-4AB9-B88C-2825D14A7242}"/>
+                <a16:creationId xmlns:a16="http://schemas.microsoft.com/office/drawing/2014/main" id="{600A3A45-08FF-43DA-BE91-568BAA907E10}"/>
               </a:ext>
             </a:extLst>
           </p:cNvPr>
@@ -6193,7 +6193,7 @@
           <p:cNvPr id="11" name="Content-Placeholder-9-11">
             <a:extLst xmlns:a="http://schemas.openxmlformats.org/drawingml/2006/main">
               <a:ext uri="{FF2B5EF4-FFF2-40B4-BE49-F238E27FC236}">
-                <a16:creationId xmlns:a16="http://schemas.microsoft.com/office/drawing/2014/main" id="{EA4913A4-7C18-4BF7-9534-88A8A90AD9D3}"/>
+                <a16:creationId xmlns:a16="http://schemas.microsoft.com/office/drawing/2014/main" id="{486F810E-09E5-4B24-88C9-07A1AA4CAF3E}"/>
               </a:ext>
             </a:extLst>
           </p:cNvPr>
@@ -6250,7 +6250,7 @@
           <p:cNvPr id="12" name="Content-Placeholder-15-12">
             <a:extLst xmlns:a="http://schemas.openxmlformats.org/drawingml/2006/main">
               <a:ext uri="{FF2B5EF4-FFF2-40B4-BE49-F238E27FC236}">
-                <a16:creationId xmlns:a16="http://schemas.microsoft.com/office/drawing/2014/main" id="{1C49E54B-3113-4292-88FC-9785AEBE1B3C}"/>
+                <a16:creationId xmlns:a16="http://schemas.microsoft.com/office/drawing/2014/main" id="{3EF81859-14C5-4586-AE43-B9EA73709454}"/>
               </a:ext>
             </a:extLst>
           </p:cNvPr>
@@ -6332,7 +6332,7 @@
     </p:spTree>
     <p:extLst>
       <p:ext uri="{BB962C8B-B14F-4D97-AF65-F5344CB8AC3E}">
-        <p14:creationId xmlns:p14="http://schemas.microsoft.com/office/powerpoint/2010/main" val="854062137"/>
+        <p14:creationId xmlns:p14="http://schemas.microsoft.com/office/powerpoint/2010/main" val="1593166435"/>
       </p:ext>
     </p:extLst>
   </p:cSld>

</xml_diff>